<commit_message>
Add Event Mode pack, expression colours and partner slide changes
- Core deck: partner slide heading and line swapped; body now says we
  help capture what people say and think, and help them remember.
- Core deck: game, app, stays and partners signalled with core-palette
  markers.
- New Event Mode pack (15 slides) from slides 14-22 of the October deck,
  same style, with open decisions flagged.
- Brand Brain 04: expression colours proposed (core palette only).

Co-Authored-By: Claude Opus 5.5 <noreply@anthropic.com>
Claude-Session: https://claude.ai/code/session_012JYWa7EuArd2TznyfiWkZR
</commit_message>
<xml_diff>
--- a/decks/Entre Amis - core brand story - DRAFT.pptx
+++ b/decks/Entre Amis - core brand story - DRAFT.pptx
@@ -121,12 +121,12 @@
   <p:extLst>
     <p:ext uri="{521415D9-36F7-43E2-AB2F-B90AF26B5E84}">
       <p14:sectionLst xmlns:p14="http://schemas.microsoft.com/office/powerpoint/2010/main">
-        <p14:section name="Introduction" id="{f63eab41-143d-59d7-3341-6c1c4bd049e9}">
+        <p14:section name="Introduction" id="{d81daebf-a435-ca6f-9308-80124c575ce4}">
           <p14:sldIdLst>
             <p14:sldId id="256"/>
           </p14:sldIdLst>
         </p14:section>
-        <p14:section name="The brand" id="{92f85f2d-e4b8-ecde-e01f-a6cc86c15255}">
+        <p14:section name="The brand" id="{ebf8077d-2faa-305c-9c82-48e6b1a2f0b1}">
           <p14:sldIdLst>
             <p14:sldId id="257"/>
             <p14:sldId id="258"/>
@@ -134,7 +134,7 @@
             <p14:sldId id="260"/>
           </p14:sldIdLst>
         </p14:section>
-        <p14:section name="What we're building" id="{d59f5213-64ce-64cc-cad9-a37f737a5e38}">
+        <p14:section name="What we're building" id="{5e3328f8-5497-46af-ccaa-0c78b8fb8fa2}">
           <p14:sldIdLst>
             <p14:sldId id="261"/>
             <p14:sldId id="262"/>
@@ -142,20 +142,20 @@
             <p14:sldId id="264"/>
           </p14:sldIdLst>
         </p14:section>
-        <p14:section name="About us" id="{8c83e646-f30d-6c54-aae9-fa4da0b30b82}">
+        <p14:section name="About us" id="{b279c7bc-57e7-d92f-91e1-3594f9fdcf30}">
           <p14:sldIdLst>
             <p14:sldId id="265"/>
             <p14:sldId id="266"/>
           </p14:sldIdLst>
         </p14:section>
-        <p14:section name="Close" id="{b24a0b33-d2a7-e8aa-25dd-99b18eb5727d}">
+        <p14:section name="Close" id="{2520edc1-5a63-6fc3-d931-ea0c1e7889ef}">
           <p14:sldIdLst>
             <p14:sldId id="267"/>
             <p14:sldId id="268"/>
             <p14:sldId id="269"/>
           </p14:sldIdLst>
         </p14:section>
-        <p14:section name="Working notes — delete before sharing" id="{c94944e3-ed9a-c94a-a2be-279ed5a11ada}">
+        <p14:section name="Working notes — delete before sharing" id="{07d4b9db-b974-5f97-28e8-3dc2e8e5ea86}">
           <p14:sldIdLst>
             <p14:sldId id="270"/>
           </p14:sldIdLst>
@@ -1798,7 +1798,7 @@
           <a:p>
             <a:r>
               <a:rPr lang="en-US" dirty="0"/>
-              <a:t>'Useful insight' is renamed because 'insight' as a product is internal language. Contact sharing (proposed, needs legal review) is not mentioned here; it belongs in the partner decks once confirmed. 'Make wines more memorable' is reworded to avoid a benefit claim.</a:t>
+              <a:t>Heading and supporting line swapped so the slide says who it is for first. Body reworded (founder, 11 October): we help capture what people say and think, and help them remember. 'Useful insight' is renamed because 'insight' as a product is internal language. Contact sharing (proposed, needs legal review) is not mentioned here; it belongs in the partner decks once confirmed. 'Make wines more memorable' is reworded to avoid a benefit claim.</a:t>
             </a:r>
             <a:endParaRPr lang="en-US" dirty="0"/>
           </a:p>
@@ -1997,7 +1997,7 @@
         <p:spPr>
           <a:xfrm>
             <a:off x="548640" y="411480"/>
-            <a:ext cx="9326880" cy="685800"/>
+            <a:ext cx="8138160" cy="685800"/>
           </a:xfrm>
           <a:prstGeom prst="rect">
             <a:avLst/>
@@ -2720,7 +2720,7 @@
         <p:spPr>
           <a:xfrm>
             <a:off x="548640" y="411480"/>
-            <a:ext cx="9326880" cy="685800"/>
+            <a:ext cx="8138160" cy="685800"/>
           </a:xfrm>
           <a:prstGeom prst="rect">
             <a:avLst/>
@@ -3529,7 +3529,7 @@
         <p:spPr>
           <a:xfrm>
             <a:off x="548640" y="411480"/>
-            <a:ext cx="9326880" cy="685800"/>
+            <a:ext cx="8138160" cy="685800"/>
           </a:xfrm>
           <a:prstGeom prst="rect">
             <a:avLst/>
@@ -4044,7 +4044,7 @@
         <p:spPr>
           <a:xfrm>
             <a:off x="548640" y="411480"/>
-            <a:ext cx="9326880" cy="685800"/>
+            <a:ext cx="8138160" cy="685800"/>
           </a:xfrm>
           <a:prstGeom prst="rect">
             <a:avLst/>
@@ -4689,7 +4689,7 @@
         <p:spPr>
           <a:xfrm>
             <a:off x="548640" y="411480"/>
-            <a:ext cx="9326880" cy="685800"/>
+            <a:ext cx="8138160" cy="685800"/>
           </a:xfrm>
           <a:prstGeom prst="rect">
             <a:avLst/>
@@ -4762,7 +4762,50 @@
       </p:sp>
       <p:sp>
         <p:nvSpPr>
-          <p:cNvPr id="4" name="Stays statement"/>
+          <p:cNvPr id="4" name="Expression marker: ENTRE AMIS STAYS"/>
+          <p:cNvSpPr txBox="1"/>
+          <p:nvPr/>
+        </p:nvSpPr>
+        <p:spPr>
+          <a:xfrm>
+            <a:off x="8716975" y="457200"/>
+            <a:ext cx="2926080" cy="384048"/>
+          </a:xfrm>
+          <a:prstGeom prst="roundRect">
+            <a:avLst>
+              <a:gd name="adj" fmla="val 50000"/>
+            </a:avLst>
+          </a:prstGeom>
+          <a:solidFill>
+            <a:schemeClr val="accent3"/>
+          </a:solidFill>
+          <a:ln/>
+        </p:spPr>
+        <p:txBody>
+          <a:bodyPr wrap="square" lIns="0" tIns="0" rIns="0" bIns="0" rtlCol="0" anchor="ctr"/>
+          <a:lstStyle/>
+          <a:p>
+            <a:pPr algn="ctr" indent="0" marL="0">
+              <a:buNone/>
+            </a:pPr>
+            <a:r>
+              <a:rPr lang="en-US" sz="1400" spc="150" kern="0" dirty="0">
+                <a:solidFill>
+                  <a:schemeClr val="tx1"/>
+                </a:solidFill>
+                <a:latin typeface="Raleway SemiBold" pitchFamily="34" charset="0"/>
+                <a:ea typeface="Raleway SemiBold" pitchFamily="34" charset="-122"/>
+                <a:cs typeface="Raleway SemiBold" pitchFamily="34" charset="-120"/>
+              </a:rPr>
+              <a:t>ENTRE AMIS STAYS</a:t>
+            </a:r>
+            <a:endParaRPr lang="en-US" sz="1400" dirty="0"/>
+          </a:p>
+        </p:txBody>
+      </p:sp>
+      <p:sp>
+        <p:nvSpPr>
+          <p:cNvPr id="5" name="Stays statement"/>
           <p:cNvSpPr/>
           <p:nvPr/>
         </p:nvSpPr>
@@ -4789,7 +4832,7 @@
       </p:sp>
       <p:sp>
         <p:nvSpPr>
-          <p:cNvPr id="5" name="Text 3"/>
+          <p:cNvPr id="6" name="Text 4"/>
           <p:cNvSpPr txBox="1"/>
           <p:nvPr/>
         </p:nvSpPr>
@@ -4862,7 +4905,7 @@
       </p:sp>
       <p:sp>
         <p:nvSpPr>
-          <p:cNvPr id="6" name="Stays details"/>
+          <p:cNvPr id="7" name="Stays details"/>
           <p:cNvSpPr/>
           <p:nvPr/>
         </p:nvSpPr>
@@ -4896,7 +4939,7 @@
       </p:sp>
       <p:sp>
         <p:nvSpPr>
-          <p:cNvPr id="7" name="Text 5"/>
+          <p:cNvPr id="8" name="Text 6"/>
           <p:cNvSpPr txBox="1"/>
           <p:nvPr/>
         </p:nvSpPr>
@@ -5026,7 +5069,7 @@
       </p:sp>
       <p:sp>
         <p:nvSpPr>
-          <p:cNvPr id="8" name="Text 6"/>
+          <p:cNvPr id="9" name="Text 7"/>
           <p:cNvSpPr txBox="1"/>
           <p:nvPr/>
         </p:nvSpPr>
@@ -5065,7 +5108,7 @@
       </p:sp>
       <p:sp>
         <p:nvSpPr>
-          <p:cNvPr id="9" name="FLAG — delete before sharing"/>
+          <p:cNvPr id="10" name="FLAG — delete before sharing"/>
           <p:cNvSpPr txBox="1"/>
           <p:nvPr/>
         </p:nvSpPr>
@@ -5347,7 +5390,7 @@
         <p:spPr>
           <a:xfrm>
             <a:off x="548640" y="411480"/>
-            <a:ext cx="9326880" cy="685800"/>
+            <a:ext cx="8138160" cy="685800"/>
           </a:xfrm>
           <a:prstGeom prst="rect">
             <a:avLst/>
@@ -5904,7 +5947,7 @@
         <p:spPr>
           <a:xfrm>
             <a:off x="548640" y="411480"/>
-            <a:ext cx="9326880" cy="685800"/>
+            <a:ext cx="8138160" cy="685800"/>
           </a:xfrm>
           <a:prstGeom prst="rect">
             <a:avLst/>
@@ -6655,7 +6698,7 @@
         <p:spPr>
           <a:xfrm>
             <a:off x="548640" y="411480"/>
-            <a:ext cx="9326880" cy="685800"/>
+            <a:ext cx="8138160" cy="685800"/>
           </a:xfrm>
           <a:prstGeom prst="rect">
             <a:avLst/>
@@ -7206,7 +7249,7 @@
         <p:spPr>
           <a:xfrm>
             <a:off x="548640" y="411480"/>
-            <a:ext cx="9326880" cy="685800"/>
+            <a:ext cx="8138160" cy="685800"/>
           </a:xfrm>
           <a:prstGeom prst="rect">
             <a:avLst/>
@@ -7766,7 +7809,7 @@
         <p:spPr>
           <a:xfrm>
             <a:off x="548640" y="411480"/>
-            <a:ext cx="9326880" cy="685800"/>
+            <a:ext cx="8138160" cy="685800"/>
           </a:xfrm>
           <a:prstGeom prst="rect">
             <a:avLst/>
@@ -8555,7 +8598,7 @@
         <p:spPr>
           <a:xfrm>
             <a:off x="548640" y="411480"/>
-            <a:ext cx="9326880" cy="685800"/>
+            <a:ext cx="8138160" cy="685800"/>
           </a:xfrm>
           <a:prstGeom prst="rect">
             <a:avLst/>
@@ -8953,35 +8996,36 @@
       </p:sp>
       <p:sp>
         <p:nvSpPr>
-          <p:cNvPr id="13" name="Text 11"/>
+          <p:cNvPr id="13" name="Expression marker: THE GAME"/>
           <p:cNvSpPr txBox="1"/>
           <p:nvPr/>
         </p:nvSpPr>
         <p:spPr>
           <a:xfrm>
             <a:off x="777240" y="2743200"/>
-            <a:ext cx="2110664" cy="2011680"/>
-          </a:xfrm>
-          <a:prstGeom prst="rect">
-            <a:avLst/>
-          </a:prstGeom>
-          <a:noFill/>
+            <a:ext cx="2110664" cy="384048"/>
+          </a:xfrm>
+          <a:prstGeom prst="roundRect">
+            <a:avLst>
+              <a:gd name="adj" fmla="val 50000"/>
+            </a:avLst>
+          </a:prstGeom>
+          <a:solidFill>
+            <a:schemeClr val="tx1"/>
+          </a:solidFill>
           <a:ln/>
         </p:spPr>
         <p:txBody>
-          <a:bodyPr wrap="square" lIns="0" tIns="0" rIns="0" bIns="0" rtlCol="0" anchor="t"/>
-          <a:lstStyle/>
-          <a:p>
-            <a:pPr indent="0" marL="0">
-              <a:spcAft>
-                <a:spcPts val="400"/>
-              </a:spcAft>
-              <a:buNone/>
-            </a:pPr>
-            <a:r>
-              <a:rPr lang="en-US" sz="1200" spc="150" kern="0" dirty="0">
-                <a:solidFill>
-                  <a:schemeClr val="tx1"/>
+          <a:bodyPr wrap="square" lIns="0" tIns="0" rIns="0" bIns="0" rtlCol="0" anchor="ctr"/>
+          <a:lstStyle/>
+          <a:p>
+            <a:pPr algn="ctr" indent="0" marL="0">
+              <a:buNone/>
+            </a:pPr>
+            <a:r>
+              <a:rPr lang="en-US" sz="1400" spc="150" kern="0" dirty="0">
+                <a:solidFill>
+                  <a:schemeClr val="bg2"/>
                 </a:solidFill>
                 <a:latin typeface="Raleway SemiBold" pitchFamily="34" charset="0"/>
                 <a:ea typeface="Raleway SemiBold" pitchFamily="34" charset="-122"/>
@@ -8991,6 +9035,28 @@
             </a:r>
             <a:endParaRPr lang="en-US" sz="1400" dirty="0"/>
           </a:p>
+        </p:txBody>
+      </p:sp>
+      <p:sp>
+        <p:nvSpPr>
+          <p:cNvPr id="14" name="Text 12"/>
+          <p:cNvSpPr txBox="1"/>
+          <p:nvPr/>
+        </p:nvSpPr>
+        <p:spPr>
+          <a:xfrm>
+            <a:off x="777240" y="3291840"/>
+            <a:ext cx="2110664" cy="1463040"/>
+          </a:xfrm>
+          <a:prstGeom prst="rect">
+            <a:avLst/>
+          </a:prstGeom>
+          <a:noFill/>
+          <a:ln/>
+        </p:spPr>
+        <p:txBody>
+          <a:bodyPr wrap="square" lIns="0" tIns="0" rIns="0" bIns="0" rtlCol="0" anchor="t"/>
+          <a:lstStyle/>
           <a:p>
             <a:pPr indent="0" marL="0">
               <a:spcAft>
@@ -8999,37 +9065,20 @@
               <a:buNone/>
             </a:pPr>
             <a:r>
-              <a:rPr lang="en-US" sz="600" dirty="0">
-                <a:solidFill>
-                  <a:schemeClr val="tx1"/>
-                </a:solidFill>
-              </a:rPr>
-              <a:t> </a:t>
+              <a:rPr lang="en-US" sz="1400" dirty="0">
+                <a:solidFill>
+                  <a:schemeClr val="tx1"/>
+                </a:solidFill>
+              </a:rPr>
+              <a:t>A premium, giftable table game that turns any wine into conversation.</a:t>
             </a:r>
             <a:endParaRPr lang="en-US" sz="1400" dirty="0"/>
           </a:p>
-          <a:p>
-            <a:pPr indent="0" marL="0">
-              <a:spcAft>
-                <a:spcPts val="400"/>
-              </a:spcAft>
-              <a:buNone/>
-            </a:pPr>
-            <a:r>
-              <a:rPr lang="en-US" sz="1400" dirty="0">
-                <a:solidFill>
-                  <a:schemeClr val="tx1"/>
-                </a:solidFill>
-              </a:rPr>
-              <a:t>A premium, giftable table game that turns any wine into conversation.</a:t>
-            </a:r>
-            <a:endParaRPr lang="en-US" sz="1400" dirty="0"/>
-          </a:p>
-        </p:txBody>
-      </p:sp>
-      <p:sp>
-        <p:nvSpPr>
-          <p:cNvPr id="14" name="Stage tag"/>
+        </p:txBody>
+      </p:sp>
+      <p:sp>
+        <p:nvSpPr>
+          <p:cNvPr id="15" name="Stage tag"/>
           <p:cNvSpPr txBox="1"/>
           <p:nvPr/>
         </p:nvSpPr>
@@ -9044,9 +9093,13 @@
             </a:avLst>
           </a:prstGeom>
           <a:solidFill>
-            <a:schemeClr val="accent4"/>
+            <a:schemeClr val="bg2"/>
           </a:solidFill>
-          <a:ln/>
+          <a:ln w="12700">
+            <a:solidFill>
+              <a:schemeClr val="tx1"/>
+            </a:solidFill>
+          </a:ln>
         </p:spPr>
         <p:txBody>
           <a:bodyPr wrap="square" lIns="0" tIns="0" rIns="0" bIns="0" rtlCol="0" anchor="ctr"/>
@@ -9072,7 +9125,7 @@
       </p:sp>
       <p:sp>
         <p:nvSpPr>
-          <p:cNvPr id="15" name="Offer: THE APP"/>
+          <p:cNvPr id="16" name="Offer: THE APP"/>
           <p:cNvSpPr/>
           <p:nvPr/>
         </p:nvSpPr>
@@ -9106,35 +9159,36 @@
       </p:sp>
       <p:sp>
         <p:nvSpPr>
-          <p:cNvPr id="16" name="Text 14"/>
+          <p:cNvPr id="17" name="Expression marker: THE APP"/>
           <p:cNvSpPr txBox="1"/>
           <p:nvPr/>
         </p:nvSpPr>
         <p:spPr>
           <a:xfrm>
             <a:off x="3619424" y="2743200"/>
-            <a:ext cx="2110664" cy="2011680"/>
-          </a:xfrm>
-          <a:prstGeom prst="rect">
-            <a:avLst/>
-          </a:prstGeom>
-          <a:noFill/>
+            <a:ext cx="2110664" cy="384048"/>
+          </a:xfrm>
+          <a:prstGeom prst="roundRect">
+            <a:avLst>
+              <a:gd name="adj" fmla="val 50000"/>
+            </a:avLst>
+          </a:prstGeom>
+          <a:solidFill>
+            <a:schemeClr val="accent2"/>
+          </a:solidFill>
           <a:ln/>
         </p:spPr>
         <p:txBody>
-          <a:bodyPr wrap="square" lIns="0" tIns="0" rIns="0" bIns="0" rtlCol="0" anchor="t"/>
-          <a:lstStyle/>
-          <a:p>
-            <a:pPr indent="0" marL="0">
-              <a:spcAft>
-                <a:spcPts val="400"/>
-              </a:spcAft>
-              <a:buNone/>
-            </a:pPr>
-            <a:r>
-              <a:rPr lang="en-US" sz="1200" spc="150" kern="0" dirty="0">
-                <a:solidFill>
-                  <a:schemeClr val="tx1"/>
+          <a:bodyPr wrap="square" lIns="0" tIns="0" rIns="0" bIns="0" rtlCol="0" anchor="ctr"/>
+          <a:lstStyle/>
+          <a:p>
+            <a:pPr algn="ctr" indent="0" marL="0">
+              <a:buNone/>
+            </a:pPr>
+            <a:r>
+              <a:rPr lang="en-US" sz="1400" spc="150" kern="0" dirty="0">
+                <a:solidFill>
+                  <a:schemeClr val="bg1"/>
                 </a:solidFill>
                 <a:latin typeface="Raleway SemiBold" pitchFamily="34" charset="0"/>
                 <a:ea typeface="Raleway SemiBold" pitchFamily="34" charset="-122"/>
@@ -9144,6 +9198,28 @@
             </a:r>
             <a:endParaRPr lang="en-US" sz="1400" dirty="0"/>
           </a:p>
+        </p:txBody>
+      </p:sp>
+      <p:sp>
+        <p:nvSpPr>
+          <p:cNvPr id="18" name="Text 16"/>
+          <p:cNvSpPr txBox="1"/>
+          <p:nvPr/>
+        </p:nvSpPr>
+        <p:spPr>
+          <a:xfrm>
+            <a:off x="3619424" y="3291840"/>
+            <a:ext cx="2110664" cy="1463040"/>
+          </a:xfrm>
+          <a:prstGeom prst="rect">
+            <a:avLst/>
+          </a:prstGeom>
+          <a:noFill/>
+          <a:ln/>
+        </p:spPr>
+        <p:txBody>
+          <a:bodyPr wrap="square" lIns="0" tIns="0" rIns="0" bIns="0" rtlCol="0" anchor="t"/>
+          <a:lstStyle/>
           <a:p>
             <a:pPr indent="0" marL="0">
               <a:spcAft>
@@ -9152,37 +9228,20 @@
               <a:buNone/>
             </a:pPr>
             <a:r>
-              <a:rPr lang="en-US" sz="600" dirty="0">
-                <a:solidFill>
-                  <a:schemeClr val="tx1"/>
-                </a:solidFill>
-              </a:rPr>
-              <a:t> </a:t>
+              <a:rPr lang="en-US" sz="1400" dirty="0">
+                <a:solidFill>
+                  <a:schemeClr val="tx1"/>
+                </a:solidFill>
+              </a:rPr>
+              <a:t>Hosts the game, adds plain-English wine information when curiosity appears, and keeps the wines and moments people want to remember.</a:t>
             </a:r>
             <a:endParaRPr lang="en-US" sz="1400" dirty="0"/>
           </a:p>
-          <a:p>
-            <a:pPr indent="0" marL="0">
-              <a:spcAft>
-                <a:spcPts val="400"/>
-              </a:spcAft>
-              <a:buNone/>
-            </a:pPr>
-            <a:r>
-              <a:rPr lang="en-US" sz="1400" dirty="0">
-                <a:solidFill>
-                  <a:schemeClr val="tx1"/>
-                </a:solidFill>
-              </a:rPr>
-              <a:t>Hosts the game, adds plain-English wine information when curiosity appears, and keeps the wines and moments people want to remember.</a:t>
-            </a:r>
-            <a:endParaRPr lang="en-US" sz="1400" dirty="0"/>
-          </a:p>
-        </p:txBody>
-      </p:sp>
-      <p:sp>
-        <p:nvSpPr>
-          <p:cNvPr id="17" name="Stage tag"/>
+        </p:txBody>
+      </p:sp>
+      <p:sp>
+        <p:nvSpPr>
+          <p:cNvPr id="19" name="Stage tag"/>
           <p:cNvSpPr txBox="1"/>
           <p:nvPr/>
         </p:nvSpPr>
@@ -9197,9 +9256,13 @@
             </a:avLst>
           </a:prstGeom>
           <a:solidFill>
-            <a:schemeClr val="accent4"/>
+            <a:schemeClr val="bg2"/>
           </a:solidFill>
-          <a:ln/>
+          <a:ln w="12700">
+            <a:solidFill>
+              <a:schemeClr val="tx1"/>
+            </a:solidFill>
+          </a:ln>
         </p:spPr>
         <p:txBody>
           <a:bodyPr wrap="square" lIns="0" tIns="0" rIns="0" bIns="0" rtlCol="0" anchor="ctr"/>
@@ -9225,7 +9288,7 @@
       </p:sp>
       <p:sp>
         <p:nvSpPr>
-          <p:cNvPr id="18" name="Offer: ENTRE AMIS STAYS"/>
+          <p:cNvPr id="20" name="Offer: ENTRE AMIS STAYS"/>
           <p:cNvSpPr/>
           <p:nvPr/>
         </p:nvSpPr>
@@ -9259,33 +9322,34 @@
       </p:sp>
       <p:sp>
         <p:nvSpPr>
-          <p:cNvPr id="19" name="Text 17"/>
+          <p:cNvPr id="21" name="Expression marker: ENTRE AMIS STAYS"/>
           <p:cNvSpPr txBox="1"/>
           <p:nvPr/>
         </p:nvSpPr>
         <p:spPr>
           <a:xfrm>
             <a:off x="6461608" y="2743200"/>
-            <a:ext cx="2110664" cy="2011680"/>
-          </a:xfrm>
-          <a:prstGeom prst="rect">
-            <a:avLst/>
-          </a:prstGeom>
-          <a:noFill/>
+            <a:ext cx="2110664" cy="384048"/>
+          </a:xfrm>
+          <a:prstGeom prst="roundRect">
+            <a:avLst>
+              <a:gd name="adj" fmla="val 50000"/>
+            </a:avLst>
+          </a:prstGeom>
+          <a:solidFill>
+            <a:schemeClr val="accent3"/>
+          </a:solidFill>
           <a:ln/>
         </p:spPr>
         <p:txBody>
-          <a:bodyPr wrap="square" lIns="0" tIns="0" rIns="0" bIns="0" rtlCol="0" anchor="t"/>
-          <a:lstStyle/>
-          <a:p>
-            <a:pPr indent="0" marL="0">
-              <a:spcAft>
-                <a:spcPts val="400"/>
-              </a:spcAft>
-              <a:buNone/>
-            </a:pPr>
-            <a:r>
-              <a:rPr lang="en-US" sz="1200" spc="150" kern="0" dirty="0">
+          <a:bodyPr wrap="square" lIns="0" tIns="0" rIns="0" bIns="0" rtlCol="0" anchor="ctr"/>
+          <a:lstStyle/>
+          <a:p>
+            <a:pPr algn="ctr" indent="0" marL="0">
+              <a:buNone/>
+            </a:pPr>
+            <a:r>
+              <a:rPr lang="en-US" sz="1400" spc="150" kern="0" dirty="0">
                 <a:solidFill>
                   <a:schemeClr val="tx1"/>
                 </a:solidFill>
@@ -9297,6 +9361,28 @@
             </a:r>
             <a:endParaRPr lang="en-US" sz="1400" dirty="0"/>
           </a:p>
+        </p:txBody>
+      </p:sp>
+      <p:sp>
+        <p:nvSpPr>
+          <p:cNvPr id="22" name="Text 20"/>
+          <p:cNvSpPr txBox="1"/>
+          <p:nvPr/>
+        </p:nvSpPr>
+        <p:spPr>
+          <a:xfrm>
+            <a:off x="6461608" y="3291840"/>
+            <a:ext cx="2110664" cy="1463040"/>
+          </a:xfrm>
+          <a:prstGeom prst="rect">
+            <a:avLst/>
+          </a:prstGeom>
+          <a:noFill/>
+          <a:ln/>
+        </p:spPr>
+        <p:txBody>
+          <a:bodyPr wrap="square" lIns="0" tIns="0" rIns="0" bIns="0" rtlCol="0" anchor="t"/>
+          <a:lstStyle/>
           <a:p>
             <a:pPr indent="0" marL="0">
               <a:spcAft>
@@ -9305,37 +9391,20 @@
               <a:buNone/>
             </a:pPr>
             <a:r>
-              <a:rPr lang="en-US" sz="600" dirty="0">
-                <a:solidFill>
-                  <a:schemeClr val="tx1"/>
-                </a:solidFill>
-              </a:rPr>
-              <a:t> </a:t>
+              <a:rPr lang="en-US" sz="1400" dirty="0">
+                <a:solidFill>
+                  <a:schemeClr val="tx1"/>
+                </a:solidFill>
+              </a:rPr>
+              <a:t>Entre Amis lived for a few days, rather than played for an evening.</a:t>
             </a:r>
             <a:endParaRPr lang="en-US" sz="1400" dirty="0"/>
           </a:p>
-          <a:p>
-            <a:pPr indent="0" marL="0">
-              <a:spcAft>
-                <a:spcPts val="400"/>
-              </a:spcAft>
-              <a:buNone/>
-            </a:pPr>
-            <a:r>
-              <a:rPr lang="en-US" sz="1400" dirty="0">
-                <a:solidFill>
-                  <a:schemeClr val="tx1"/>
-                </a:solidFill>
-              </a:rPr>
-              <a:t>Entre Amis lived for a few days, rather than played for an evening.</a:t>
-            </a:r>
-            <a:endParaRPr lang="en-US" sz="1400" dirty="0"/>
-          </a:p>
-        </p:txBody>
-      </p:sp>
-      <p:sp>
-        <p:nvSpPr>
-          <p:cNvPr id="20" name="Stage tag"/>
+        </p:txBody>
+      </p:sp>
+      <p:sp>
+        <p:nvSpPr>
+          <p:cNvPr id="23" name="Stage tag"/>
           <p:cNvSpPr txBox="1"/>
           <p:nvPr/>
         </p:nvSpPr>
@@ -9350,9 +9419,13 @@
             </a:avLst>
           </a:prstGeom>
           <a:solidFill>
-            <a:schemeClr val="accent4"/>
+            <a:schemeClr val="bg2"/>
           </a:solidFill>
-          <a:ln/>
+          <a:ln w="12700">
+            <a:solidFill>
+              <a:schemeClr val="tx1"/>
+            </a:solidFill>
+          </a:ln>
         </p:spPr>
         <p:txBody>
           <a:bodyPr wrap="square" lIns="0" tIns="0" rIns="0" bIns="0" rtlCol="0" anchor="ctr"/>
@@ -9378,7 +9451,7 @@
       </p:sp>
       <p:sp>
         <p:nvSpPr>
-          <p:cNvPr id="21" name="Offer: WITH PARTNERS"/>
+          <p:cNvPr id="24" name="Offer: WITH PARTNERS"/>
           <p:cNvSpPr/>
           <p:nvPr/>
         </p:nvSpPr>
@@ -9412,33 +9485,34 @@
       </p:sp>
       <p:sp>
         <p:nvSpPr>
-          <p:cNvPr id="22" name="Text 20"/>
+          <p:cNvPr id="25" name="Expression marker: WITH PARTNERS"/>
           <p:cNvSpPr txBox="1"/>
           <p:nvPr/>
         </p:nvSpPr>
         <p:spPr>
           <a:xfrm>
             <a:off x="9303791" y="2743200"/>
-            <a:ext cx="2110664" cy="2011680"/>
-          </a:xfrm>
-          <a:prstGeom prst="rect">
-            <a:avLst/>
-          </a:prstGeom>
-          <a:noFill/>
+            <a:ext cx="2110664" cy="384048"/>
+          </a:xfrm>
+          <a:prstGeom prst="roundRect">
+            <a:avLst>
+              <a:gd name="adj" fmla="val 50000"/>
+            </a:avLst>
+          </a:prstGeom>
+          <a:solidFill>
+            <a:schemeClr val="accent4"/>
+          </a:solidFill>
           <a:ln/>
         </p:spPr>
         <p:txBody>
-          <a:bodyPr wrap="square" lIns="0" tIns="0" rIns="0" bIns="0" rtlCol="0" anchor="t"/>
-          <a:lstStyle/>
-          <a:p>
-            <a:pPr indent="0" marL="0">
-              <a:spcAft>
-                <a:spcPts val="400"/>
-              </a:spcAft>
-              <a:buNone/>
-            </a:pPr>
-            <a:r>
-              <a:rPr lang="en-US" sz="1200" spc="150" kern="0" dirty="0">
+          <a:bodyPr wrap="square" lIns="0" tIns="0" rIns="0" bIns="0" rtlCol="0" anchor="ctr"/>
+          <a:lstStyle/>
+          <a:p>
+            <a:pPr algn="ctr" indent="0" marL="0">
+              <a:buNone/>
+            </a:pPr>
+            <a:r>
+              <a:rPr lang="en-US" sz="1400" spc="150" kern="0" dirty="0">
                 <a:solidFill>
                   <a:schemeClr val="tx1"/>
                 </a:solidFill>
@@ -9450,6 +9524,28 @@
             </a:r>
             <a:endParaRPr lang="en-US" sz="1400" dirty="0"/>
           </a:p>
+        </p:txBody>
+      </p:sp>
+      <p:sp>
+        <p:nvSpPr>
+          <p:cNvPr id="26" name="Text 24"/>
+          <p:cNvSpPr txBox="1"/>
+          <p:nvPr/>
+        </p:nvSpPr>
+        <p:spPr>
+          <a:xfrm>
+            <a:off x="9303791" y="3291840"/>
+            <a:ext cx="2110664" cy="1463040"/>
+          </a:xfrm>
+          <a:prstGeom prst="rect">
+            <a:avLst/>
+          </a:prstGeom>
+          <a:noFill/>
+          <a:ln/>
+        </p:spPr>
+        <p:txBody>
+          <a:bodyPr wrap="square" lIns="0" tIns="0" rIns="0" bIns="0" rtlCol="0" anchor="t"/>
+          <a:lstStyle/>
           <a:p>
             <a:pPr indent="0" marL="0">
               <a:spcAft>
@@ -9458,37 +9554,20 @@
               <a:buNone/>
             </a:pPr>
             <a:r>
-              <a:rPr lang="en-US" sz="600" dirty="0">
-                <a:solidFill>
-                  <a:schemeClr val="tx1"/>
-                </a:solidFill>
-              </a:rPr>
-              <a:t> </a:t>
+              <a:rPr lang="en-US" sz="1400" dirty="0">
+                <a:solidFill>
+                  <a:schemeClr val="tx1"/>
+                </a:solidFill>
+              </a:rPr>
+              <a:t>Partner Mode and Event Mode. Bringing the Entre Amis table to vineyards, retailers, wine clubs and wine events.</a:t>
             </a:r>
             <a:endParaRPr lang="en-US" sz="1400" dirty="0"/>
           </a:p>
-          <a:p>
-            <a:pPr indent="0" marL="0">
-              <a:spcAft>
-                <a:spcPts val="400"/>
-              </a:spcAft>
-              <a:buNone/>
-            </a:pPr>
-            <a:r>
-              <a:rPr lang="en-US" sz="1400" dirty="0">
-                <a:solidFill>
-                  <a:schemeClr val="tx1"/>
-                </a:solidFill>
-              </a:rPr>
-              <a:t>Partner Mode and Event Mode. Bringing the Entre Amis table to vineyards, retailers, wine clubs and wine events.</a:t>
-            </a:r>
-            <a:endParaRPr lang="en-US" sz="1400" dirty="0"/>
-          </a:p>
-        </p:txBody>
-      </p:sp>
-      <p:sp>
-        <p:nvSpPr>
-          <p:cNvPr id="23" name="Stage tag"/>
+        </p:txBody>
+      </p:sp>
+      <p:sp>
+        <p:nvSpPr>
+          <p:cNvPr id="27" name="Stage tag"/>
           <p:cNvSpPr txBox="1"/>
           <p:nvPr/>
         </p:nvSpPr>
@@ -9503,9 +9582,13 @@
             </a:avLst>
           </a:prstGeom>
           <a:solidFill>
-            <a:schemeClr val="accent4"/>
+            <a:schemeClr val="bg2"/>
           </a:solidFill>
-          <a:ln/>
+          <a:ln w="12700">
+            <a:solidFill>
+              <a:schemeClr val="tx1"/>
+            </a:solidFill>
+          </a:ln>
         </p:spPr>
         <p:txBody>
           <a:bodyPr wrap="square" lIns="0" tIns="0" rIns="0" bIns="0" rtlCol="0" anchor="ctr"/>
@@ -9531,7 +9614,7 @@
       </p:sp>
       <p:sp>
         <p:nvSpPr>
-          <p:cNvPr id="24" name="FLAG — delete before sharing"/>
+          <p:cNvPr id="28" name="FLAG — delete before sharing"/>
           <p:cNvSpPr txBox="1"/>
           <p:nvPr/>
         </p:nvSpPr>
@@ -9587,7 +9670,7 @@
       </p:sp>
       <p:sp>
         <p:nvSpPr>
-          <p:cNvPr id="25" name="FLAG — delete before sharing"/>
+          <p:cNvPr id="29" name="FLAG — delete before sharing"/>
           <p:cNvSpPr txBox="1"/>
           <p:nvPr/>
         </p:nvSpPr>
@@ -9725,7 +9808,7 @@
         <p:spPr>
           <a:xfrm>
             <a:off x="548640" y="411480"/>
-            <a:ext cx="9326880" cy="685800"/>
+            <a:ext cx="8138160" cy="685800"/>
           </a:xfrm>
           <a:prstGeom prst="rect">
             <a:avLst/>
@@ -9798,14 +9881,14 @@
       </p:sp>
       <p:sp>
         <p:nvSpPr>
-          <p:cNvPr id="4" name="Stage tag"/>
+          <p:cNvPr id="4" name="Expression marker: THE GAME"/>
           <p:cNvSpPr txBox="1"/>
           <p:nvPr/>
         </p:nvSpPr>
         <p:spPr>
           <a:xfrm>
-            <a:off x="9905695" y="502920"/>
-            <a:ext cx="1737360" cy="292608"/>
+            <a:off x="9265615" y="457200"/>
+            <a:ext cx="2377440" cy="384048"/>
           </a:xfrm>
           <a:prstGeom prst="roundRect">
             <a:avLst>
@@ -9813,7 +9896,7 @@
             </a:avLst>
           </a:prstGeom>
           <a:solidFill>
-            <a:schemeClr val="accent4"/>
+            <a:schemeClr val="tx1"/>
           </a:solidFill>
           <a:ln/>
         </p:spPr>
@@ -9825,14 +9908,61 @@
               <a:buNone/>
             </a:pPr>
             <a:r>
-              <a:rPr lang="en-US" sz="1200" dirty="0">
-                <a:solidFill>
-                  <a:schemeClr val="tx1"/>
+              <a:rPr lang="en-US" sz="1400" spc="150" kern="0" dirty="0">
+                <a:solidFill>
+                  <a:schemeClr val="bg2"/>
                 </a:solidFill>
                 <a:latin typeface="Raleway SemiBold" pitchFamily="34" charset="0"/>
                 <a:ea typeface="Raleway SemiBold" pitchFamily="34" charset="-122"/>
                 <a:cs typeface="Raleway SemiBold" pitchFamily="34" charset="-120"/>
               </a:rPr>
+              <a:t>THE GAME</a:t>
+            </a:r>
+            <a:endParaRPr lang="en-US" sz="1400" dirty="0"/>
+          </a:p>
+        </p:txBody>
+      </p:sp>
+      <p:sp>
+        <p:nvSpPr>
+          <p:cNvPr id="5" name="Stage tag"/>
+          <p:cNvSpPr txBox="1"/>
+          <p:nvPr/>
+        </p:nvSpPr>
+        <p:spPr>
+          <a:xfrm>
+            <a:off x="9265615" y="914400"/>
+            <a:ext cx="2377440" cy="292608"/>
+          </a:xfrm>
+          <a:prstGeom prst="roundRect">
+            <a:avLst>
+              <a:gd name="adj" fmla="val 50000"/>
+            </a:avLst>
+          </a:prstGeom>
+          <a:solidFill>
+            <a:schemeClr val="bg2"/>
+          </a:solidFill>
+          <a:ln w="12700">
+            <a:solidFill>
+              <a:schemeClr val="tx1"/>
+            </a:solidFill>
+          </a:ln>
+        </p:spPr>
+        <p:txBody>
+          <a:bodyPr wrap="square" lIns="0" tIns="0" rIns="0" bIns="0" rtlCol="0" anchor="ctr"/>
+          <a:lstStyle/>
+          <a:p>
+            <a:pPr algn="ctr" indent="0" marL="0">
+              <a:buNone/>
+            </a:pPr>
+            <a:r>
+              <a:rPr lang="en-US" sz="1200" dirty="0">
+                <a:solidFill>
+                  <a:schemeClr val="tx1"/>
+                </a:solidFill>
+                <a:latin typeface="Raleway SemiBold" pitchFamily="34" charset="0"/>
+                <a:ea typeface="Raleway SemiBold" pitchFamily="34" charset="-122"/>
+                <a:cs typeface="Raleway SemiBold" pitchFamily="34" charset="-120"/>
+              </a:rPr>
               <a:t>In development</a:t>
             </a:r>
             <a:endParaRPr lang="en-US" sz="1200" dirty="0"/>
@@ -9841,7 +9971,7 @@
       </p:sp>
       <p:sp>
         <p:nvSpPr>
-          <p:cNvPr id="5" name="Image placeholder"/>
+          <p:cNvPr id="6" name="Image placeholder"/>
           <p:cNvSpPr/>
           <p:nvPr/>
         </p:nvSpPr>
@@ -9868,7 +9998,7 @@
       </p:sp>
       <p:sp>
         <p:nvSpPr>
-          <p:cNvPr id="6" name="Text 4"/>
+          <p:cNvPr id="7" name="Text 5"/>
           <p:cNvSpPr txBox="1"/>
           <p:nvPr/>
         </p:nvSpPr>
@@ -9910,7 +10040,7 @@
       </p:sp>
       <p:sp>
         <p:nvSpPr>
-          <p:cNvPr id="7" name="Text 5"/>
+          <p:cNvPr id="8" name="Text 6"/>
           <p:cNvSpPr txBox="1"/>
           <p:nvPr/>
         </p:nvSpPr>
@@ -9949,7 +10079,7 @@
       </p:sp>
       <p:sp>
         <p:nvSpPr>
-          <p:cNvPr id="8" name="Text 6"/>
+          <p:cNvPr id="9" name="Text 7"/>
           <p:cNvSpPr txBox="1"/>
           <p:nvPr/>
         </p:nvSpPr>
@@ -10002,7 +10132,7 @@
       </p:sp>
       <p:sp>
         <p:nvSpPr>
-          <p:cNvPr id="9" name="Family colour: Savour"/>
+          <p:cNvPr id="10" name="Family colour: Savour"/>
           <p:cNvSpPr/>
           <p:nvPr/>
         </p:nvSpPr>
@@ -10027,7 +10157,7 @@
       </p:sp>
       <p:sp>
         <p:nvSpPr>
-          <p:cNvPr id="10" name="Text 8"/>
+          <p:cNvPr id="11" name="Text 9"/>
           <p:cNvSpPr txBox="1"/>
           <p:nvPr/>
         </p:nvSpPr>
@@ -10083,7 +10213,7 @@
       </p:sp>
       <p:sp>
         <p:nvSpPr>
-          <p:cNvPr id="11" name="Family colour: Pour"/>
+          <p:cNvPr id="12" name="Family colour: Pour"/>
           <p:cNvSpPr/>
           <p:nvPr/>
         </p:nvSpPr>
@@ -10108,7 +10238,7 @@
       </p:sp>
       <p:sp>
         <p:nvSpPr>
-          <p:cNvPr id="12" name="Text 10"/>
+          <p:cNvPr id="13" name="Text 11"/>
           <p:cNvSpPr txBox="1"/>
           <p:nvPr/>
         </p:nvSpPr>
@@ -10164,7 +10294,7 @@
       </p:sp>
       <p:sp>
         <p:nvSpPr>
-          <p:cNvPr id="13" name="Family colour: Mischief"/>
+          <p:cNvPr id="14" name="Family colour: Mischief"/>
           <p:cNvSpPr/>
           <p:nvPr/>
         </p:nvSpPr>
@@ -10189,7 +10319,7 @@
       </p:sp>
       <p:sp>
         <p:nvSpPr>
-          <p:cNvPr id="14" name="Text 12"/>
+          <p:cNvPr id="15" name="Text 13"/>
           <p:cNvSpPr txBox="1"/>
           <p:nvPr/>
         </p:nvSpPr>
@@ -10245,7 +10375,7 @@
       </p:sp>
       <p:sp>
         <p:nvSpPr>
-          <p:cNvPr id="15" name="Family colour: Wild"/>
+          <p:cNvPr id="16" name="Family colour: Wild"/>
           <p:cNvSpPr/>
           <p:nvPr/>
         </p:nvSpPr>
@@ -10270,7 +10400,7 @@
       </p:sp>
       <p:sp>
         <p:nvSpPr>
-          <p:cNvPr id="16" name="Text 14"/>
+          <p:cNvPr id="17" name="Text 15"/>
           <p:cNvSpPr txBox="1"/>
           <p:nvPr/>
         </p:nvSpPr>
@@ -10326,7 +10456,7 @@
       </p:sp>
       <p:sp>
         <p:nvSpPr>
-          <p:cNvPr id="17" name="Family colour: Secret Missions"/>
+          <p:cNvPr id="18" name="Family colour: Secret Missions"/>
           <p:cNvSpPr/>
           <p:nvPr/>
         </p:nvSpPr>
@@ -10351,7 +10481,7 @@
       </p:sp>
       <p:sp>
         <p:nvSpPr>
-          <p:cNvPr id="18" name="Text 16"/>
+          <p:cNvPr id="19" name="Text 17"/>
           <p:cNvSpPr txBox="1"/>
           <p:nvPr/>
         </p:nvSpPr>
@@ -10407,7 +10537,7 @@
       </p:sp>
       <p:sp>
         <p:nvSpPr>
-          <p:cNvPr id="19" name="Text 17"/>
+          <p:cNvPr id="20" name="Text 18"/>
           <p:cNvSpPr txBox="1"/>
           <p:nvPr/>
         </p:nvSpPr>
@@ -10463,7 +10593,7 @@
       </p:sp>
       <p:sp>
         <p:nvSpPr>
-          <p:cNvPr id="20" name="Fact: 2–8 PLAYERS"/>
+          <p:cNvPr id="21" name="Fact: 2–8 PLAYERS"/>
           <p:cNvSpPr/>
           <p:nvPr/>
         </p:nvSpPr>
@@ -10497,7 +10627,7 @@
       </p:sp>
       <p:sp>
         <p:nvSpPr>
-          <p:cNvPr id="21" name="Text 19"/>
+          <p:cNvPr id="22" name="Text 20"/>
           <p:cNvSpPr txBox="1"/>
           <p:nvPr/>
         </p:nvSpPr>
@@ -10556,7 +10686,7 @@
       </p:sp>
       <p:sp>
         <p:nvSpPr>
-          <p:cNvPr id="22" name="Fact: ANY WINE"/>
+          <p:cNvPr id="23" name="Fact: ANY WINE"/>
           <p:cNvSpPr/>
           <p:nvPr/>
         </p:nvSpPr>
@@ -10590,7 +10720,7 @@
       </p:sp>
       <p:sp>
         <p:nvSpPr>
-          <p:cNvPr id="23" name="Text 21"/>
+          <p:cNvPr id="24" name="Text 22"/>
           <p:cNvSpPr txBox="1"/>
           <p:nvPr/>
         </p:nvSpPr>
@@ -10649,7 +10779,7 @@
       </p:sp>
       <p:sp>
         <p:nvSpPr>
-          <p:cNvPr id="24" name="Fact: ANY TIME OF DAY"/>
+          <p:cNvPr id="25" name="Fact: ANY TIME OF DAY"/>
           <p:cNvSpPr/>
           <p:nvPr/>
         </p:nvSpPr>
@@ -10683,7 +10813,7 @@
       </p:sp>
       <p:sp>
         <p:nvSpPr>
-          <p:cNvPr id="25" name="Text 23"/>
+          <p:cNvPr id="26" name="Text 24"/>
           <p:cNvSpPr txBox="1"/>
           <p:nvPr/>
         </p:nvSpPr>
@@ -10742,7 +10872,7 @@
       </p:sp>
       <p:sp>
         <p:nvSpPr>
-          <p:cNvPr id="26" name="Fact: NO APP NEEDED"/>
+          <p:cNvPr id="27" name="Fact: NO APP NEEDED"/>
           <p:cNvSpPr/>
           <p:nvPr/>
         </p:nvSpPr>
@@ -10776,7 +10906,7 @@
       </p:sp>
       <p:sp>
         <p:nvSpPr>
-          <p:cNvPr id="27" name="Text 25"/>
+          <p:cNvPr id="28" name="Text 26"/>
           <p:cNvSpPr txBox="1"/>
           <p:nvPr/>
         </p:nvSpPr>
@@ -10835,7 +10965,7 @@
       </p:sp>
       <p:sp>
         <p:nvSpPr>
-          <p:cNvPr id="28" name="Fact: 18+"/>
+          <p:cNvPr id="29" name="Fact: 18+"/>
           <p:cNvSpPr/>
           <p:nvPr/>
         </p:nvSpPr>
@@ -10869,7 +10999,7 @@
       </p:sp>
       <p:sp>
         <p:nvSpPr>
-          <p:cNvPr id="29" name="Text 27"/>
+          <p:cNvPr id="30" name="Text 28"/>
           <p:cNvSpPr txBox="1"/>
           <p:nvPr/>
         </p:nvSpPr>
@@ -10928,7 +11058,7 @@
       </p:sp>
       <p:sp>
         <p:nvSpPr>
-          <p:cNvPr id="30" name="FLAG — delete before sharing"/>
+          <p:cNvPr id="31" name="FLAG — delete before sharing"/>
           <p:cNvSpPr txBox="1"/>
           <p:nvPr/>
         </p:nvSpPr>
@@ -11066,7 +11196,7 @@
         <p:spPr>
           <a:xfrm>
             <a:off x="548640" y="411480"/>
-            <a:ext cx="9326880" cy="685800"/>
+            <a:ext cx="8138160" cy="685800"/>
           </a:xfrm>
           <a:prstGeom prst="rect">
             <a:avLst/>
@@ -11139,14 +11269,14 @@
       </p:sp>
       <p:sp>
         <p:nvSpPr>
-          <p:cNvPr id="4" name="Stage tag"/>
+          <p:cNvPr id="4" name="Expression marker: THE APP"/>
           <p:cNvSpPr txBox="1"/>
           <p:nvPr/>
         </p:nvSpPr>
         <p:spPr>
           <a:xfrm>
-            <a:off x="9905695" y="502920"/>
-            <a:ext cx="1737360" cy="292608"/>
+            <a:off x="9265615" y="457200"/>
+            <a:ext cx="2377440" cy="384048"/>
           </a:xfrm>
           <a:prstGeom prst="roundRect">
             <a:avLst>
@@ -11154,7 +11284,7 @@
             </a:avLst>
           </a:prstGeom>
           <a:solidFill>
-            <a:schemeClr val="accent4"/>
+            <a:schemeClr val="accent2"/>
           </a:solidFill>
           <a:ln/>
         </p:spPr>
@@ -11166,14 +11296,61 @@
               <a:buNone/>
             </a:pPr>
             <a:r>
-              <a:rPr lang="en-US" sz="1200" dirty="0">
-                <a:solidFill>
-                  <a:schemeClr val="tx1"/>
+              <a:rPr lang="en-US" sz="1400" spc="150" kern="0" dirty="0">
+                <a:solidFill>
+                  <a:schemeClr val="bg1"/>
                 </a:solidFill>
                 <a:latin typeface="Raleway SemiBold" pitchFamily="34" charset="0"/>
                 <a:ea typeface="Raleway SemiBold" pitchFamily="34" charset="-122"/>
                 <a:cs typeface="Raleway SemiBold" pitchFamily="34" charset="-120"/>
               </a:rPr>
+              <a:t>THE APP</a:t>
+            </a:r>
+            <a:endParaRPr lang="en-US" sz="1400" dirty="0"/>
+          </a:p>
+        </p:txBody>
+      </p:sp>
+      <p:sp>
+        <p:nvSpPr>
+          <p:cNvPr id="5" name="Stage tag"/>
+          <p:cNvSpPr txBox="1"/>
+          <p:nvPr/>
+        </p:nvSpPr>
+        <p:spPr>
+          <a:xfrm>
+            <a:off x="9265615" y="914400"/>
+            <a:ext cx="2377440" cy="292608"/>
+          </a:xfrm>
+          <a:prstGeom prst="roundRect">
+            <a:avLst>
+              <a:gd name="adj" fmla="val 50000"/>
+            </a:avLst>
+          </a:prstGeom>
+          <a:solidFill>
+            <a:schemeClr val="bg2"/>
+          </a:solidFill>
+          <a:ln w="12700">
+            <a:solidFill>
+              <a:schemeClr val="tx1"/>
+            </a:solidFill>
+          </a:ln>
+        </p:spPr>
+        <p:txBody>
+          <a:bodyPr wrap="square" lIns="0" tIns="0" rIns="0" bIns="0" rtlCol="0" anchor="ctr"/>
+          <a:lstStyle/>
+          <a:p>
+            <a:pPr algn="ctr" indent="0" marL="0">
+              <a:buNone/>
+            </a:pPr>
+            <a:r>
+              <a:rPr lang="en-US" sz="1200" dirty="0">
+                <a:solidFill>
+                  <a:schemeClr val="tx1"/>
+                </a:solidFill>
+                <a:latin typeface="Raleway SemiBold" pitchFamily="34" charset="0"/>
+                <a:ea typeface="Raleway SemiBold" pitchFamily="34" charset="-122"/>
+                <a:cs typeface="Raleway SemiBold" pitchFamily="34" charset="-120"/>
+              </a:rPr>
               <a:t>In development</a:t>
             </a:r>
             <a:endParaRPr lang="en-US" sz="1200" dirty="0"/>
@@ -11182,7 +11359,7 @@
       </p:sp>
       <p:sp>
         <p:nvSpPr>
-          <p:cNvPr id="5" name="App features"/>
+          <p:cNvPr id="6" name="App features"/>
           <p:cNvSpPr/>
           <p:nvPr/>
         </p:nvSpPr>
@@ -11216,7 +11393,7 @@
       </p:sp>
       <p:sp>
         <p:nvSpPr>
-          <p:cNvPr id="6" name="Text 4"/>
+          <p:cNvPr id="7" name="Text 5"/>
           <p:cNvSpPr txBox="1"/>
           <p:nvPr/>
         </p:nvSpPr>
@@ -11364,7 +11541,7 @@
       </p:sp>
       <p:sp>
         <p:nvSpPr>
-          <p:cNvPr id="7" name="Text 5"/>
+          <p:cNvPr id="8" name="Text 6"/>
           <p:cNvSpPr txBox="1"/>
           <p:nvPr/>
         </p:nvSpPr>
@@ -11406,7 +11583,7 @@
       </p:sp>
       <p:sp>
         <p:nvSpPr>
-          <p:cNvPr id="8" name="Image placeholder"/>
+          <p:cNvPr id="9" name="Image placeholder"/>
           <p:cNvSpPr/>
           <p:nvPr/>
         </p:nvSpPr>
@@ -11433,7 +11610,7 @@
       </p:sp>
       <p:sp>
         <p:nvSpPr>
-          <p:cNvPr id="9" name="Text 7"/>
+          <p:cNvPr id="10" name="Text 8"/>
           <p:cNvSpPr txBox="1"/>
           <p:nvPr/>
         </p:nvSpPr>
@@ -11475,7 +11652,7 @@
       </p:sp>
       <p:sp>
         <p:nvSpPr>
-          <p:cNvPr id="10" name="Image placeholder"/>
+          <p:cNvPr id="11" name="Image placeholder"/>
           <p:cNvSpPr/>
           <p:nvPr/>
         </p:nvSpPr>
@@ -11502,7 +11679,7 @@
       </p:sp>
       <p:sp>
         <p:nvSpPr>
-          <p:cNvPr id="11" name="Text 9"/>
+          <p:cNvPr id="12" name="Text 10"/>
           <p:cNvSpPr txBox="1"/>
           <p:nvPr/>
         </p:nvSpPr>
@@ -11626,7 +11803,7 @@
         <p:spPr>
           <a:xfrm>
             <a:off x="548640" y="411480"/>
-            <a:ext cx="9326880" cy="685800"/>
+            <a:ext cx="8138160" cy="685800"/>
           </a:xfrm>
           <a:prstGeom prst="rect">
             <a:avLst/>
@@ -11650,7 +11827,7 @@
                 <a:ea typeface="Raleway Light" pitchFamily="34" charset="-122"/>
                 <a:cs typeface="Raleway Light" pitchFamily="34" charset="-120"/>
               </a:rPr>
-              <a:t>What we add isn't content. It's connection.</a:t>
+              <a:t>For vineyards, retailers, wine clubs and wine events</a:t>
             </a:r>
             <a:endParaRPr lang="en-US" sz="3600" dirty="0"/>
           </a:p>
@@ -11659,15 +11836,13 @@
       <p:sp>
         <p:nvSpPr>
           <p:cNvPr id="3" name="Text 1"/>
-          <p:cNvSpPr/>
-          <p:nvPr>
-            <p:ph idx="103" type="body" hasCustomPrompt="1"/>
-          </p:nvPr>
-        </p:nvSpPr>
-        <p:spPr>
-          <a:xfrm>
-            <a:off x="548640" y="1115568"/>
-            <a:ext cx="11094415" cy="411480"/>
+          <p:cNvSpPr txBox="1"/>
+          <p:nvPr/>
+        </p:nvSpPr>
+        <p:spPr>
+          <a:xfrm>
+            <a:off x="548640" y="1536192"/>
+            <a:ext cx="11094415" cy="365760"/>
           </a:xfrm>
           <a:prstGeom prst="rect">
             <a:avLst/>
@@ -11679,7 +11854,10 @@
           <a:bodyPr wrap="square" lIns="0" tIns="0" rIns="0" bIns="0" rtlCol="0" anchor="t"/>
           <a:lstStyle/>
           <a:p>
-            <a:pPr algn="l" indent="0" marL="0">
+            <a:pPr indent="0" marL="0">
+              <a:spcAft>
+                <a:spcPts val="400"/>
+              </a:spcAft>
               <a:buNone/>
             </a:pPr>
             <a:r>
@@ -11687,11 +11865,8 @@
                 <a:solidFill>
                   <a:schemeClr val="tx1"/>
                 </a:solidFill>
-                <a:latin typeface="Raleway Light" pitchFamily="34" charset="0"/>
-                <a:ea typeface="Raleway Light" pitchFamily="34" charset="-122"/>
-                <a:cs typeface="Raleway Light" pitchFamily="34" charset="-120"/>
-              </a:rPr>
-              <a:t>For vineyards, retailers, wine clubs and wine events</a:t>
+              </a:rPr>
+              <a:t>What we add isn't content. It's connection.</a:t>
             </a:r>
             <a:endParaRPr lang="en-US" sz="1800" dirty="0"/>
           </a:p>
@@ -11699,14 +11874,57 @@
       </p:sp>
       <p:sp>
         <p:nvSpPr>
-          <p:cNvPr id="4" name="Text 2"/>
+          <p:cNvPr id="4" name="Expression marker: PARTNERS"/>
           <p:cNvSpPr txBox="1"/>
           <p:nvPr/>
         </p:nvSpPr>
         <p:spPr>
           <a:xfrm>
-            <a:off x="548640" y="1737360"/>
-            <a:ext cx="11094415" cy="640080"/>
+            <a:off x="9265615" y="457200"/>
+            <a:ext cx="2377440" cy="384048"/>
+          </a:xfrm>
+          <a:prstGeom prst="roundRect">
+            <a:avLst>
+              <a:gd name="adj" fmla="val 50000"/>
+            </a:avLst>
+          </a:prstGeom>
+          <a:solidFill>
+            <a:schemeClr val="accent4"/>
+          </a:solidFill>
+          <a:ln/>
+        </p:spPr>
+        <p:txBody>
+          <a:bodyPr wrap="square" lIns="0" tIns="0" rIns="0" bIns="0" rtlCol="0" anchor="ctr"/>
+          <a:lstStyle/>
+          <a:p>
+            <a:pPr algn="ctr" indent="0" marL="0">
+              <a:buNone/>
+            </a:pPr>
+            <a:r>
+              <a:rPr lang="en-US" sz="1400" spc="150" kern="0" dirty="0">
+                <a:solidFill>
+                  <a:schemeClr val="tx1"/>
+                </a:solidFill>
+                <a:latin typeface="Raleway SemiBold" pitchFamily="34" charset="0"/>
+                <a:ea typeface="Raleway SemiBold" pitchFamily="34" charset="-122"/>
+                <a:cs typeface="Raleway SemiBold" pitchFamily="34" charset="-120"/>
+              </a:rPr>
+              <a:t>PARTNERS</a:t>
+            </a:r>
+            <a:endParaRPr lang="en-US" sz="1400" dirty="0"/>
+          </a:p>
+        </p:txBody>
+      </p:sp>
+      <p:sp>
+        <p:nvSpPr>
+          <p:cNvPr id="5" name="Text 3"/>
+          <p:cNvSpPr txBox="1"/>
+          <p:nvPr/>
+        </p:nvSpPr>
+        <p:spPr>
+          <a:xfrm>
+            <a:off x="548640" y="1965960"/>
+            <a:ext cx="11094415" cy="594360"/>
           </a:xfrm>
           <a:prstGeom prst="rect">
             <a:avLst/>
@@ -11730,7 +11948,7 @@
                   <a:schemeClr val="tx1"/>
                 </a:solidFill>
               </a:rPr>
-              <a:t>Wine businesses already have stories, tasting notes and expertise. We add the social side: people talking about your wines, saying what they really think, and remembering them afterwards.</a:t>
+              <a:t>Wine businesses already have stories, tasting notes and expertise. We help capture what people say and really think about your wines, and help them remember those wines afterwards.</a:t>
             </a:r>
             <a:endParaRPr lang="en-US" sz="1600" dirty="0"/>
           </a:p>
@@ -11738,18 +11956,18 @@
       </p:sp>
       <p:sp>
         <p:nvSpPr>
-          <p:cNvPr id="5" name="Card: BETWEEN PEOPLE"/>
+          <p:cNvPr id="6" name="Card: BETWEEN PEOPLE"/>
           <p:cNvSpPr/>
           <p:nvPr/>
         </p:nvSpPr>
         <p:spPr>
           <a:xfrm>
-            <a:off x="548640" y="2514600"/>
-            <a:ext cx="2567864" cy="1691640"/>
+            <a:off x="548640" y="2606040"/>
+            <a:ext cx="2567864" cy="1783080"/>
           </a:xfrm>
           <a:prstGeom prst="roundRect">
             <a:avLst>
-              <a:gd name="adj" fmla="val 6486"/>
+              <a:gd name="adj" fmla="val 6154"/>
             </a:avLst>
           </a:prstGeom>
           <a:solidFill>
@@ -11772,14 +11990,14 @@
       </p:sp>
       <p:sp>
         <p:nvSpPr>
-          <p:cNvPr id="6" name="Text 4"/>
+          <p:cNvPr id="7" name="Text 5"/>
           <p:cNvSpPr txBox="1"/>
           <p:nvPr/>
         </p:nvSpPr>
         <p:spPr>
           <a:xfrm>
-            <a:off x="777240" y="2743200"/>
-            <a:ext cx="2110664" cy="1325880"/>
+            <a:off x="777240" y="2834640"/>
+            <a:ext cx="2110664" cy="1417320"/>
           </a:xfrm>
           <a:prstGeom prst="rect">
             <a:avLst/>
@@ -11848,18 +12066,18 @@
       </p:sp>
       <p:sp>
         <p:nvSpPr>
-          <p:cNvPr id="7" name="Card: WITH THE WINE"/>
+          <p:cNvPr id="8" name="Card: WITH THE WINE"/>
           <p:cNvSpPr/>
           <p:nvPr/>
         </p:nvSpPr>
         <p:spPr>
           <a:xfrm>
-            <a:off x="3390824" y="2514600"/>
-            <a:ext cx="2567864" cy="1691640"/>
+            <a:off x="3390824" y="2606040"/>
+            <a:ext cx="2567864" cy="1783080"/>
           </a:xfrm>
           <a:prstGeom prst="roundRect">
             <a:avLst>
-              <a:gd name="adj" fmla="val 6486"/>
+              <a:gd name="adj" fmla="val 6154"/>
             </a:avLst>
           </a:prstGeom>
           <a:solidFill>
@@ -11882,14 +12100,14 @@
       </p:sp>
       <p:sp>
         <p:nvSpPr>
-          <p:cNvPr id="8" name="Text 6"/>
+          <p:cNvPr id="9" name="Text 7"/>
           <p:cNvSpPr txBox="1"/>
           <p:nvPr/>
         </p:nvSpPr>
         <p:spPr>
           <a:xfrm>
-            <a:off x="3619424" y="2743200"/>
-            <a:ext cx="2110664" cy="1325880"/>
+            <a:off x="3619424" y="2834640"/>
+            <a:ext cx="2110664" cy="1417320"/>
           </a:xfrm>
           <a:prstGeom prst="rect">
             <a:avLst/>
@@ -11958,18 +12176,18 @@
       </p:sp>
       <p:sp>
         <p:nvSpPr>
-          <p:cNvPr id="9" name="Card: BEYOND THE MOMENT"/>
+          <p:cNvPr id="10" name="Card: BEYOND THE MOMENT"/>
           <p:cNvSpPr/>
           <p:nvPr/>
         </p:nvSpPr>
         <p:spPr>
           <a:xfrm>
-            <a:off x="6233008" y="2514600"/>
-            <a:ext cx="2567864" cy="1691640"/>
+            <a:off x="6233008" y="2606040"/>
+            <a:ext cx="2567864" cy="1783080"/>
           </a:xfrm>
           <a:prstGeom prst="roundRect">
             <a:avLst>
-              <a:gd name="adj" fmla="val 6486"/>
+              <a:gd name="adj" fmla="val 6154"/>
             </a:avLst>
           </a:prstGeom>
           <a:solidFill>
@@ -11992,14 +12210,14 @@
       </p:sp>
       <p:sp>
         <p:nvSpPr>
-          <p:cNvPr id="10" name="Text 8"/>
+          <p:cNvPr id="11" name="Text 9"/>
           <p:cNvSpPr txBox="1"/>
           <p:nvPr/>
         </p:nvSpPr>
         <p:spPr>
           <a:xfrm>
-            <a:off x="6461608" y="2743200"/>
-            <a:ext cx="2110664" cy="1325880"/>
+            <a:off x="6461608" y="2834640"/>
+            <a:ext cx="2110664" cy="1417320"/>
           </a:xfrm>
           <a:prstGeom prst="rect">
             <a:avLst/>
@@ -12068,18 +12286,18 @@
       </p:sp>
       <p:sp>
         <p:nvSpPr>
-          <p:cNvPr id="11" name="Card: WHAT PEOPLE REALLY THINK"/>
+          <p:cNvPr id="12" name="Card: WHAT PEOPLE REALLY THINK"/>
           <p:cNvSpPr/>
           <p:nvPr/>
         </p:nvSpPr>
         <p:spPr>
           <a:xfrm>
-            <a:off x="9075191" y="2514600"/>
-            <a:ext cx="2567864" cy="1691640"/>
+            <a:off x="9075191" y="2606040"/>
+            <a:ext cx="2567864" cy="1783080"/>
           </a:xfrm>
           <a:prstGeom prst="roundRect">
             <a:avLst>
-              <a:gd name="adj" fmla="val 6486"/>
+              <a:gd name="adj" fmla="val 6154"/>
             </a:avLst>
           </a:prstGeom>
           <a:solidFill>
@@ -12102,14 +12320,14 @@
       </p:sp>
       <p:sp>
         <p:nvSpPr>
-          <p:cNvPr id="12" name="Text 10"/>
+          <p:cNvPr id="13" name="Text 11"/>
           <p:cNvSpPr txBox="1"/>
           <p:nvPr/>
         </p:nvSpPr>
         <p:spPr>
           <a:xfrm>
-            <a:off x="9303791" y="2743200"/>
-            <a:ext cx="2110664" cy="1325880"/>
+            <a:off x="9303791" y="2834640"/>
+            <a:ext cx="2110664" cy="1417320"/>
           </a:xfrm>
           <a:prstGeom prst="rect">
             <a:avLst/>
@@ -12178,18 +12396,18 @@
       </p:sp>
       <p:sp>
         <p:nvSpPr>
-          <p:cNvPr id="13" name="Two ways in"/>
+          <p:cNvPr id="14" name="Two ways in"/>
           <p:cNvSpPr/>
           <p:nvPr/>
         </p:nvSpPr>
         <p:spPr>
           <a:xfrm>
-            <a:off x="548640" y="4434840"/>
-            <a:ext cx="7863840" cy="1417320"/>
+            <a:off x="548640" y="4572000"/>
+            <a:ext cx="7863840" cy="1325880"/>
           </a:xfrm>
           <a:prstGeom prst="roundRect">
             <a:avLst>
-              <a:gd name="adj" fmla="val 7742"/>
+              <a:gd name="adj" fmla="val 8276"/>
             </a:avLst>
           </a:prstGeom>
           <a:solidFill>
@@ -12205,14 +12423,14 @@
       </p:sp>
       <p:sp>
         <p:nvSpPr>
-          <p:cNvPr id="14" name="Text 12"/>
+          <p:cNvPr id="15" name="Text 13"/>
           <p:cNvSpPr txBox="1"/>
           <p:nvPr/>
         </p:nvSpPr>
         <p:spPr>
           <a:xfrm>
-            <a:off x="868680" y="4572000"/>
-            <a:ext cx="7315200" cy="1371600"/>
+            <a:off x="868680" y="4681728"/>
+            <a:ext cx="7315200" cy="1188720"/>
           </a:xfrm>
           <a:prstGeom prst="rect">
             <a:avLst/>
@@ -12349,14 +12567,14 @@
       </p:sp>
       <p:sp>
         <p:nvSpPr>
-          <p:cNvPr id="15" name="FLAG — delete before sharing"/>
+          <p:cNvPr id="16" name="FLAG — delete before sharing"/>
           <p:cNvSpPr txBox="1"/>
           <p:nvPr/>
         </p:nvSpPr>
         <p:spPr>
           <a:xfrm>
-            <a:off x="8686800" y="4434840"/>
-            <a:ext cx="2956255" cy="731520"/>
+            <a:off x="8686800" y="4572000"/>
+            <a:ext cx="2956255" cy="621792"/>
           </a:xfrm>
           <a:prstGeom prst="rect">
             <a:avLst/>
@@ -12405,14 +12623,14 @@
       </p:sp>
       <p:sp>
         <p:nvSpPr>
-          <p:cNvPr id="16" name="FLAG — delete before sharing"/>
+          <p:cNvPr id="17" name="FLAG — delete before sharing"/>
           <p:cNvSpPr txBox="1"/>
           <p:nvPr/>
         </p:nvSpPr>
         <p:spPr>
           <a:xfrm>
-            <a:off x="8686800" y="5303520"/>
-            <a:ext cx="2956255" cy="731520"/>
+            <a:off x="8686800" y="5257800"/>
+            <a:ext cx="2956255" cy="640080"/>
           </a:xfrm>
           <a:prstGeom prst="rect">
             <a:avLst/>
@@ -12456,6 +12674,36 @@
               <a:t>Event Mode's stage, and how it differs from Partner Mode.</a:t>
             </a:r>
             <a:endParaRPr lang="en-US" sz="1100" dirty="0"/>
+          </a:p>
+        </p:txBody>
+      </p:sp>
+      <p:sp>
+        <p:nvSpPr>
+          <p:cNvPr id="19" name="Text 1"/>
+          <p:cNvSpPr/>
+          <p:nvPr>
+            <p:ph idx="103" type="body" hasCustomPrompt="1"/>
+          </p:nvPr>
+        </p:nvSpPr>
+        <p:spPr>
+          <a:xfrm>
+            <a:off x="548640" y="1115568"/>
+            <a:ext cx="11094415" cy="411480"/>
+          </a:xfrm>
+          <a:prstGeom prst="rect">
+            <a:avLst/>
+          </a:prstGeom>
+          <a:noFill/>
+          <a:ln/>
+        </p:spPr>
+        <p:txBody>
+          <a:bodyPr wrap="square" lIns="0" tIns="0" rIns="0" bIns="0" rtlCol="0" anchor="t"/>
+          <a:lstStyle/>
+          <a:p>
+            <a:pPr algn="l" indent="0" marL="0">
+              <a:buNone/>
+            </a:pPr>
+            <a:endParaRPr lang="en-US" sz="1800" dirty="0"/>
           </a:p>
         </p:txBody>
       </p:sp>

</xml_diff>

<commit_message>
Record that Wine 101 and My wines are both built
Both are prototypes and may be described as in development. Data logging
behind them is incomplete: recorded as internal-only work, never external.

Co-Authored-By: Claude Opus 5.5 <noreply@anthropic.com>
Claude-Session: https://claude.ai/code/session_012JYWa7EuArd2TznyfiWkZR
</commit_message>
<xml_diff>
--- a/decks/Entre Amis - core brand story - DRAFT.pptx
+++ b/decks/Entre Amis - core brand story - DRAFT.pptx
@@ -121,12 +121,12 @@
   <p:extLst>
     <p:ext uri="{521415D9-36F7-43E2-AB2F-B90AF26B5E84}">
       <p14:sectionLst xmlns:p14="http://schemas.microsoft.com/office/powerpoint/2010/main">
-        <p14:section name="Introduction" id="{c3097012-aa5c-a7eb-39f5-91c82d98c9ca}">
+        <p14:section name="Introduction" id="{794e720c-7143-a52d-18c3-16ad5c37772c}">
           <p14:sldIdLst>
             <p14:sldId id="256"/>
           </p14:sldIdLst>
         </p14:section>
-        <p14:section name="The brand" id="{3dc37a04-47c1-3847-31bb-db3683c86d99}">
+        <p14:section name="The brand" id="{28789bc6-51b0-7654-b6a0-bbb09b2e59ee}">
           <p14:sldIdLst>
             <p14:sldId id="257"/>
             <p14:sldId id="258"/>
@@ -134,7 +134,7 @@
             <p14:sldId id="260"/>
           </p14:sldIdLst>
         </p14:section>
-        <p14:section name="What we're building" id="{b2cb11bb-9721-7b1d-2e0a-e0f721b1dc3d}">
+        <p14:section name="What we're building" id="{b9f07c08-7547-2bd4-3a55-b2c933ac96b4}">
           <p14:sldIdLst>
             <p14:sldId id="261"/>
             <p14:sldId id="262"/>
@@ -142,20 +142,20 @@
             <p14:sldId id="264"/>
           </p14:sldIdLst>
         </p14:section>
-        <p14:section name="About us" id="{49df7ad2-1192-239f-c029-6fd849f1da53}">
+        <p14:section name="About us" id="{05737ee6-cf8f-1e27-ae8c-4da14124c661}">
           <p14:sldIdLst>
             <p14:sldId id="265"/>
             <p14:sldId id="266"/>
           </p14:sldIdLst>
         </p14:section>
-        <p14:section name="Close" id="{675e23ed-b2af-ec28-1d0a-9823da4ed827}">
+        <p14:section name="Close" id="{ae967c99-21ff-c64c-09ab-f36cfa82c8ae}">
           <p14:sldIdLst>
             <p14:sldId id="267"/>
             <p14:sldId id="268"/>
             <p14:sldId id="269"/>
           </p14:sldIdLst>
         </p14:section>
-        <p14:section name="Working notes — delete before sharing" id="{2c5f07bf-f239-8a2d-e0b9-02bbb21facbd}">
+        <p14:section name="Working notes — delete before sharing" id="{b287b559-76ad-0edd-cc58-04422c15f47c}">
           <p14:sldIdLst>
             <p14:sldId id="270"/>
           </p14:sldIdLst>
@@ -11787,7 +11787,7 @@
                   <a:schemeClr val="tx1"/>
                 </a:solidFill>
               </a:rPr>
-              <a:t>Wine 101 and My wines definitions, and which of them is built.</a:t>
+              <a:t>Wine 101 and My wines definitions (proposed in the Brand Brain).</a:t>
             </a:r>
             <a:endParaRPr lang="en-US" sz="1100" dirty="0"/>
           </a:p>

</xml_diff>